<commit_message>
normalize latents before classification. updated architecture figure.
</commit_message>
<xml_diff>
--- a/writing/motorVAEGAN-architecture.pptx
+++ b/writing/motorVAEGAN-architecture.pptx
@@ -6932,6 +6932,92 @@
                 <a:schemeClr val="tx1"/>
               </a:solidFill>
             </a:endParaRPr>
+          </a:p>
+        </p:txBody>
+      </p:sp>
+      <p:sp>
+        <p:nvSpPr>
+          <p:cNvPr id="1068" name="TextBox 1067">
+            <a:extLst>
+              <a:ext uri="{FF2B5EF4-FFF2-40B4-BE49-F238E27FC236}">
+                <a16:creationId xmlns:a16="http://schemas.microsoft.com/office/drawing/2014/main" id="{EDB36AEF-B383-6C06-B8F6-F18FF03B0261}"/>
+              </a:ext>
+            </a:extLst>
+          </p:cNvPr>
+          <p:cNvSpPr txBox="1"/>
+          <p:nvPr/>
+        </p:nvSpPr>
+        <p:spPr>
+          <a:xfrm rot="20836275">
+            <a:off x="3307032" y="3822288"/>
+            <a:ext cx="828906" cy="276999"/>
+          </a:xfrm>
+          <a:prstGeom prst="rect">
+            <a:avLst/>
+          </a:prstGeom>
+          <a:noFill/>
+        </p:spPr>
+        <p:txBody>
+          <a:bodyPr wrap="square" rtlCol="0">
+            <a:spAutoFit/>
+          </a:bodyPr>
+          <a:lstStyle/>
+          <a:p>
+            <a:pPr algn="ctr"/>
+            <a:r>
+              <a:rPr lang="en-US" sz="1200" dirty="0">
+                <a:solidFill>
+                  <a:schemeClr val="tx1">
+                    <a:lumMod val="65000"/>
+                    <a:lumOff val="35000"/>
+                  </a:schemeClr>
+                </a:solidFill>
+              </a:rPr>
+              <a:t>z-score</a:t>
+            </a:r>
+          </a:p>
+        </p:txBody>
+      </p:sp>
+      <p:sp>
+        <p:nvSpPr>
+          <p:cNvPr id="1069" name="TextBox 1068">
+            <a:extLst>
+              <a:ext uri="{FF2B5EF4-FFF2-40B4-BE49-F238E27FC236}">
+                <a16:creationId xmlns:a16="http://schemas.microsoft.com/office/drawing/2014/main" id="{7FF46940-5EEF-CF6B-CCB7-EC6B273A1699}"/>
+              </a:ext>
+            </a:extLst>
+          </p:cNvPr>
+          <p:cNvSpPr txBox="1"/>
+          <p:nvPr/>
+        </p:nvSpPr>
+        <p:spPr>
+          <a:xfrm rot="2056545">
+            <a:off x="4517251" y="3761207"/>
+            <a:ext cx="828906" cy="276999"/>
+          </a:xfrm>
+          <a:prstGeom prst="rect">
+            <a:avLst/>
+          </a:prstGeom>
+          <a:noFill/>
+        </p:spPr>
+        <p:txBody>
+          <a:bodyPr wrap="square" rtlCol="0">
+            <a:spAutoFit/>
+          </a:bodyPr>
+          <a:lstStyle/>
+          <a:p>
+            <a:pPr algn="ctr"/>
+            <a:r>
+              <a:rPr lang="en-US" sz="1200" dirty="0">
+                <a:solidFill>
+                  <a:schemeClr val="tx1">
+                    <a:lumMod val="65000"/>
+                    <a:lumOff val="35000"/>
+                  </a:schemeClr>
+                </a:solidFill>
+              </a:rPr>
+              <a:t>z-score</a:t>
+            </a:r>
           </a:p>
         </p:txBody>
       </p:sp>

</xml_diff>